<commit_message>
Use generated sample files in the python-net docs
In the context of the GroupDocs.Watermark for Python via .NET 26.10
release. The sample files now come from GroupDocs.Watermark-SampleFiles,
which builds each one to contain what its examples look for and checks
it with the product.

- _sample_files: synced from the generator. 12 pages that linked
  flattened or parent-folder copies now link their own folder; the
  stale copies are removed.
- _output_files: regenerated, including the images-inside page;
  orphans under old paths removed.
- Snippets: the unprotect example opens protected-document.docx; the
  hyperlink-removal regex matches the sample's review link; the
  spreadsheet attachment examples skip linked attachments, which have
  no content.
- Prose: the PDF attachment listing and output sizes match the new
  files.
</commit_message>
<xml_diff>
--- a/python-net/_output_files/developer-guide/advanced-usage/adding-watermarks/add-watermarks-to-presentation-documents/working-with-slide-backgrounds/remove_slide_background/output.pptx
+++ b/python-net/_output_files/developer-guide/advanced-usage/adding-watermarks/add-watermarks-to-presentation-documents/working-with-slide-backgrounds/remove_slide_background/output.pptx
@@ -7,14 +7,15 @@
   </p:sldMasterIdLst>
   <p:sldIdLst>
     <p:sldId id="256" r:id="rId2"/>
-    <p:sldId id="258" r:id="rId3"/>
-    <p:sldId id="260" r:id="rId4"/>
-    <p:sldId id="262" r:id="rId5"/>
+    <p:sldId id="257" r:id="rId3"/>
+    <p:sldId id="258" r:id="rId4"/>
+    <p:sldId id="259" r:id="rId5"/>
+    <p:sldId id="260" r:id="rId6"/>
   </p:sldIdLst>
-  <p:sldSz cx="9144000" cy="6858000" type="screen4x3"/>
+  <p:sldSz cx="12192000" cy="6858000"/>
   <p:notesSz cx="6858000" cy="9144000"/>
   <p:custDataLst>
-    <p:tags r:id="rId6"/>
+    <p:tags r:id="rId7"/>
   </p:custDataLst>
   <p:defaultTextStyle>
     <a:defPPr>
@@ -111,7 +112,185 @@
       </a:defRPr>
     </a:lvl9pPr>
   </p:defaultTextStyle>
+  <p:extLst>
+    <p:ext uri="{EFAFB233-063F-42B5-8137-9DF3F51BA10A}">
+      <p15:sldGuideLst xmlns:p15="http://schemas.microsoft.com/office/powerpoint/2012/main">
+        <p15:guide id="1" orient="horz" pos="2160" userDrawn="1">
+          <p15:clr>
+            <a:srgbClr val="A4A3A4"/>
+          </p15:clr>
+        </p15:guide>
+        <p15:guide id="2" pos="2880" userDrawn="1">
+          <p15:clr>
+            <a:srgbClr val="A4A3A4"/>
+          </p15:clr>
+        </p15:guide>
+      </p15:sldGuideLst>
+    </p:ext>
+  </p:extLst>
 </p:presentation>
+</file>
+
+<file path=ppt/charts/chart1.xml><?xml version="1.0" encoding="utf-8"?>
+<c:chartSpace xmlns:a="http://schemas.openxmlformats.org/drawingml/2006/main" xmlns:r="http://schemas.openxmlformats.org/officeDocument/2006/relationships" xmlns:m="http://schemas.openxmlformats.org/officeDocument/2006/math" xmlns:w="http://schemas.openxmlformats.org/wordprocessingml/2006/main" xmlns:wp="http://schemas.openxmlformats.org/drawingml/2006/wordprocessingDrawing" xmlns:a14="http://schemas.microsoft.com/office/drawing/2010/main" xmlns:c="http://schemas.openxmlformats.org/drawingml/2006/chart">
+  <c:date1904 val="0"/>
+  <c:lang val="ru-RU"/>
+  <c:roundedCorners val="0"/>
+  <mc:AlternateContent xmlns:mc="http://schemas.openxmlformats.org/markup-compatibility/2006">
+    <mc:Choice xmlns:c14="http://schemas.microsoft.com/office/drawing/2007/8/2/chart" Requires="c14">
+      <c14:style val="102"/>
+    </mc:Choice>
+    <mc:Fallback>
+      <c:style val="2"/>
+    </mc:Fallback>
+  </mc:AlternateContent>
+  <c:chart>
+    <c:title>
+      <c:tx>
+        <c:rich>
+          <a:bodyPr/>
+          <a:lstStyle/>
+          <a:p>
+            <a:pPr>
+              <a:defRPr/>
+            </a:pPr>
+            <a:r>
+              <a:t>Reach by channel (thousands)</a:t>
+            </a:r>
+          </a:p>
+        </c:rich>
+      </c:tx>
+      <c:overlay val="1"/>
+    </c:title>
+    <c:autoTitleDeleted val="0"/>
+    <c:plotArea>
+      <c:barChart>
+        <c:barDir val="col"/>
+        <c:grouping val="clustered"/>
+        <c:varyColors val="0"/>
+        <c:ser>
+          <c:idx val="0"/>
+          <c:order val="0"/>
+          <c:tx>
+            <c:strRef>
+              <c:f>Sheet1!$B$1</c:f>
+              <c:strCache>
+                <c:ptCount val="1"/>
+                <c:pt idx="0">
+                  <c:v>Reach (thousands)</c:v>
+                </c:pt>
+              </c:strCache>
+            </c:strRef>
+          </c:tx>
+          <c:spPr>
+            <a:solidFill>
+              <a:srgbClr val="3B7DD8"/>
+            </a:solidFill>
+          </c:spPr>
+          <c:invertIfNegative val="1"/>
+          <c:cat>
+            <c:strRef>
+              <c:f>Sheet1!$A$2:$A$5</c:f>
+              <c:strCache>
+                <c:ptCount val="4"/>
+                <c:pt idx="0">
+                  <c:v>Paid social</c:v>
+                </c:pt>
+                <c:pt idx="1">
+                  <c:v>Organic social</c:v>
+                </c:pt>
+                <c:pt idx="2">
+                  <c:v>Out-of-home</c:v>
+                </c:pt>
+                <c:pt idx="3">
+                  <c:v>In-store</c:v>
+                </c:pt>
+              </c:strCache>
+            </c:strRef>
+          </c:cat>
+          <c:val>
+            <c:numRef>
+              <c:f>Sheet1!$B$2:$B$5</c:f>
+              <c:numCache>
+                <c:ptCount val="4"/>
+                <c:pt idx="0">
+                  <c:v>920</c:v>
+                </c:pt>
+                <c:pt idx="1">
+                  <c:v>610</c:v>
+                </c:pt>
+                <c:pt idx="2">
+                  <c:v>240</c:v>
+                </c:pt>
+                <c:pt idx="3">
+                  <c:v>38</c:v>
+                </c:pt>
+              </c:numCache>
+            </c:numRef>
+          </c:val>
+        </c:ser>
+        <c:dLbls>
+          <c:showLegendKey val="0"/>
+          <c:showVal val="0"/>
+          <c:showCatName val="0"/>
+          <c:showSerName val="0"/>
+          <c:showPercent val="0"/>
+          <c:showBubbleSize val="0"/>
+          <c:showLeaderLines val="0"/>
+        </c:dLbls>
+        <c:gapWidth/>
+        <c:overlap/>
+        <c:axId val="67451136"/>
+        <c:axId val="66437120"/>
+      </c:barChart>
+      <c:catAx>
+        <c:axId val="67451136"/>
+        <c:scaling>
+          <c:orientation/>
+        </c:scaling>
+        <c:delete val="0"/>
+        <c:axPos val="b"/>
+        <c:numFmt formatCode="General" sourceLinked="1"/>
+        <c:majorTickMark val="out"/>
+        <c:minorTickMark val="none"/>
+        <c:crossAx val="66437120"/>
+        <c:crosses val="autoZero"/>
+        <c:auto val="0"/>
+        <c:lblAlgn val="ctr"/>
+        <c:lblOffset/>
+        <c:noMultiLvlLbl val="0"/>
+      </c:catAx>
+      <c:valAx>
+        <c:axId val="66437120"/>
+        <c:scaling>
+          <c:orientation/>
+        </c:scaling>
+        <c:delete val="0"/>
+        <c:axPos val="l"/>
+        <c:majorGridlines/>
+        <c:numFmt formatCode="General" sourceLinked="1"/>
+        <c:majorTickMark val="out"/>
+        <c:minorTickMark val="none"/>
+        <c:crossAx val="67451136"/>
+        <c:crosses val="autoZero"/>
+        <c:crossBetween val="between"/>
+      </c:valAx>
+    </c:plotArea>
+    <c:plotVisOnly val="1"/>
+    <c:dispBlanksAs/>
+    <c:showDLblsOverMax val="1"/>
+  </c:chart>
+  <c:txPr>
+    <a:bodyPr/>
+    <a:p>
+      <a:pPr>
+        <a:defRPr sz="1800" smtId="4294967295"/>
+      </a:pPr>
+      <a:endParaRPr lang="ru-RU"/>
+    </a:p>
+  </c:txPr>
+  <c:externalData r:id="rId1"/>
+</c:chartSpace>
 </file>
 
 <file path=ppt/slideLayouts/slideLayout1.xml><?xml version="1.0" encoding="utf-8"?>
@@ -281,7 +460,7 @@
           <a:bodyPr/>
           <a:lstStyle/>
           <a:p>
-            <a:fld id="{6FCD33B4-7E75-434A-BAEE-74557F7B81C3}" type="datetimeFigureOut">
+            <a:fld id="{F16A9EB2-F56D-4BE7-BF00-2A0C07D26666}" type="datetimeFigureOut">
               <a:rPr lang="en-US" smtClean="0"/>
               <a:t>11/7/2009</a:t>
             </a:fld>
@@ -445,7 +624,7 @@
           <a:bodyPr/>
           <a:lstStyle/>
           <a:p>
-            <a:fld id="{D65AD438-B2D1-466E-9C5A-B54F725C7170}" type="datetimeFigureOut">
+            <a:fld id="{37C0E0F7-FA3E-4C3D-8D8F-D0766C195098}" type="datetimeFigureOut">
               <a:rPr lang="en-US" smtClean="0"/>
               <a:t>11/7/2009</a:t>
             </a:fld>
@@ -609,7 +788,7 @@
           <a:bodyPr/>
           <a:lstStyle/>
           <a:p>
-            <a:fld id="{1B27A162-A340-4FB8-AD4B-347F0B1767C1}" type="datetimeFigureOut">
+            <a:fld id="{60F3BF8A-BA28-45DE-BF0D-1122B9EF6F80}" type="datetimeFigureOut">
               <a:rPr lang="en-US" smtClean="0"/>
               <a:t>11/7/2009</a:t>
             </a:fld>
@@ -773,7 +952,7 @@
           <a:bodyPr/>
           <a:lstStyle/>
           <a:p>
-            <a:fld id="{405B9A22-FDFD-4A8B-8F6E-5B4070C29DEE}" type="datetimeFigureOut">
+            <a:fld id="{105069C1-B628-4F0C-80DE-9B6462575D05}" type="datetimeFigureOut">
               <a:rPr lang="en-US" smtClean="0"/>
               <a:t>11/7/2009</a:t>
             </a:fld>
@@ -1003,7 +1182,7 @@
           <a:bodyPr/>
           <a:lstStyle/>
           <a:p>
-            <a:fld id="{F6170FA7-054B-4B4C-B89E-B3EE34E8F4F4}" type="datetimeFigureOut">
+            <a:fld id="{FFF92FBB-7FE6-4B95-88A9-FC5013131AFC}" type="datetimeFigureOut">
               <a:rPr lang="en-US" smtClean="0"/>
               <a:t>11/7/2009</a:t>
             </a:fld>
@@ -1274,7 +1453,7 @@
           <a:bodyPr/>
           <a:lstStyle/>
           <a:p>
-            <a:fld id="{1868EB2C-D679-429D-BFB9-A93169BBA37D}" type="datetimeFigureOut">
+            <a:fld id="{C31BA405-D741-482F-B5FD-81865E7B9EFD}" type="datetimeFigureOut">
               <a:rPr lang="en-US" smtClean="0"/>
               <a:t>11/7/2009</a:t>
             </a:fld>
@@ -1663,7 +1842,7 @@
           <a:bodyPr/>
           <a:lstStyle/>
           <a:p>
-            <a:fld id="{4FE60FA2-A4E1-4242-8CDC-743118837FB2}" type="datetimeFigureOut">
+            <a:fld id="{CDEDA1B2-A745-4611-BD14-BBF6292891FE}" type="datetimeFigureOut">
               <a:rPr lang="en-US" smtClean="0"/>
               <a:t>11/7/2009</a:t>
             </a:fld>
@@ -1776,7 +1955,7 @@
           <a:bodyPr/>
           <a:lstStyle/>
           <a:p>
-            <a:fld id="{EBB23242-35EA-4132-8B9D-75384E105229}" type="datetimeFigureOut">
+            <a:fld id="{08EADBE4-332E-4D84-9AB8-4E6B814A4002}" type="datetimeFigureOut">
               <a:rPr lang="en-US" smtClean="0"/>
               <a:t>11/7/2009</a:t>
             </a:fld>
@@ -1866,7 +2045,7 @@
           <a:bodyPr/>
           <a:lstStyle/>
           <a:p>
-            <a:fld id="{3BDD49BC-4DAB-4D88-8DF6-CFD2E5B69EC9}" type="datetimeFigureOut">
+            <a:fld id="{5AB5442F-DBE2-47C3-9199-BB1650C9C6F9}" type="datetimeFigureOut">
               <a:rPr lang="en-US" smtClean="0"/>
               <a:t>11/7/2009</a:t>
             </a:fld>
@@ -2121,7 +2300,7 @@
           <a:bodyPr/>
           <a:lstStyle/>
           <a:p>
-            <a:fld id="{2B486F57-8E3D-4D73-BA93-5182231125B5}" type="datetimeFigureOut">
+            <a:fld id="{33EBB53A-DE69-4DDB-8DA0-2B5BF2B988C3}" type="datetimeFigureOut">
               <a:rPr lang="en-US" smtClean="0"/>
               <a:t>11/7/2009</a:t>
             </a:fld>
@@ -2353,7 +2532,7 @@
           <a:bodyPr/>
           <a:lstStyle/>
           <a:p>
-            <a:fld id="{D650AA75-29E4-4408-8628-D948495EDD70}" type="datetimeFigureOut">
+            <a:fld id="{D868838B-5429-4DF5-A973-45D34469005E}" type="datetimeFigureOut">
               <a:rPr lang="en-US" smtClean="0"/>
               <a:t>11/7/2009</a:t>
             </a:fld>
@@ -2922,9 +3101,7 @@
   <p:cSld name="">
     <p:bg>
       <p:bgPr>
-        <a:solidFill>
-          <a:srgbClr val="1B2A4A"/>
-        </a:solidFill>
+        <a:noFill/>
       </p:bgPr>
     </p:bg>
     <p:spTree>
@@ -2939,9 +3116,56 @@
           <a:ext cx="0" cy="0"/>
         </a:xfrm>
       </p:grpSpPr>
+      <p:sp>
+        <p:nvSpPr>
+          <p:cNvPr id="2" name="Title scrim" title=""/>
+          <p:cNvSpPr/>
+          <p:nvPr/>
+        </p:nvSpPr>
+        <p:spPr>
+          <a:xfrm>
+            <a:off x="0" y="1234440"/>
+            <a:ext cx="12192000" cy="3566160"/>
+          </a:xfrm>
+          <a:prstGeom prst="rect">
+            <a:avLst/>
+          </a:prstGeom>
+          <a:solidFill>
+            <a:srgbClr val="1B2A4A">
+              <a:alpha val="58824"/>
+            </a:srgbClr>
+          </a:solidFill>
+          <a:ln>
+            <a:noFill/>
+          </a:ln>
+        </p:spPr>
+        <p:style>
+          <a:lnRef idx="2">
+            <a:schemeClr val="accent1">
+              <a:shade val="50000"/>
+            </a:schemeClr>
+          </a:lnRef>
+          <a:fillRef idx="1">
+            <a:schemeClr val="accent1"/>
+          </a:fillRef>
+          <a:effectRef idx="0">
+            <a:schemeClr val="accent1"/>
+          </a:effectRef>
+          <a:fontRef idx="minor">
+            <a:schemeClr val="lt1"/>
+          </a:fontRef>
+        </p:style>
+        <p:txBody>
+          <a:bodyPr rtlCol="0" anchor="ctr"/>
+          <a:lstStyle/>
+          <a:p>
+            <a:pPr algn="ctr"/>
+          </a:p>
+        </p:txBody>
+      </p:sp>
       <p:pic>
         <p:nvPicPr>
-          <p:cNvPr id="2" name="New picture" title=""/>
+          <p:cNvPr id="3" name="Logo" title=""/>
           <p:cNvPicPr/>
           <p:nvPr/>
         </p:nvPicPr>
@@ -2953,8 +3177,8 @@
         </p:blipFill>
         <p:spPr>
           <a:xfrm>
-            <a:off x="2476500" y="1219200"/>
-            <a:ext cx="4191000" cy="1257300"/>
+            <a:off x="4191000" y="1371600"/>
+            <a:ext cx="3810000" cy="1143000"/>
           </a:xfrm>
           <a:prstGeom prst="rect">
             <a:avLst/>
@@ -2963,14 +3187,14 @@
       </p:pic>
       <p:sp>
         <p:nvSpPr>
-          <p:cNvPr id="3" name="New shape" title=""/>
-          <p:cNvSpPr/>
+          <p:cNvPr id="4" name="New shape" title=""/>
+          <p:cNvSpPr txBox="1"/>
           <p:nvPr/>
         </p:nvSpPr>
         <p:spPr>
           <a:xfrm>
-            <a:off x="762000" y="3238500"/>
-            <a:ext cx="7620000" cy="762000"/>
+            <a:off x="762000" y="2641600"/>
+            <a:ext cx="10668000" cy="711200"/>
           </a:xfrm>
           <a:prstGeom prst="rect">
             <a:avLst/>
@@ -3014,59 +3238,14 @@
       </p:sp>
       <p:sp>
         <p:nvSpPr>
-          <p:cNvPr id="4" name="New shape" title=""/>
-          <p:cNvSpPr/>
+          <p:cNvPr id="5" name="New shape" title=""/>
+          <p:cNvSpPr txBox="1"/>
           <p:nvPr/>
         </p:nvSpPr>
         <p:spPr>
           <a:xfrm>
-            <a:off x="4000500" y="4089400"/>
-            <a:ext cx="1143000" cy="50800"/>
-          </a:xfrm>
-          <a:prstGeom prst="rect">
-            <a:avLst/>
-          </a:prstGeom>
-          <a:solidFill>
-            <a:srgbClr val="E8A33D"/>
-          </a:solidFill>
-          <a:ln>
-            <a:noFill/>
-          </a:ln>
-        </p:spPr>
-        <p:style>
-          <a:lnRef idx="2">
-            <a:schemeClr val="accent1">
-              <a:shade val="50000"/>
-            </a:schemeClr>
-          </a:lnRef>
-          <a:fillRef idx="1">
-            <a:schemeClr val="accent1"/>
-          </a:fillRef>
-          <a:effectRef idx="0">
-            <a:schemeClr val="accent1"/>
-          </a:effectRef>
-          <a:fontRef idx="minor">
-            <a:schemeClr val="lt1"/>
-          </a:fontRef>
-        </p:style>
-        <p:txBody>
-          <a:bodyPr rtlCol="0" anchor="ctr"/>
-          <a:lstStyle/>
-          <a:p>
-            <a:pPr algn="ctr"/>
-          </a:p>
-        </p:txBody>
-      </p:sp>
-      <p:sp>
-        <p:nvSpPr>
-          <p:cNvPr id="5" name="New shape" title=""/>
-          <p:cNvSpPr/>
-          <p:nvPr/>
-        </p:nvSpPr>
-        <p:spPr>
-          <a:xfrm>
-            <a:off x="762000" y="4292600"/>
-            <a:ext cx="7620000" cy="508000"/>
+            <a:off x="762000" y="3403600"/>
+            <a:ext cx="10668000" cy="457200"/>
           </a:xfrm>
           <a:prstGeom prst="rect">
             <a:avLst/>
@@ -3111,13 +3290,13 @@
       <p:sp>
         <p:nvSpPr>
           <p:cNvPr id="6" name="New shape" title=""/>
-          <p:cNvSpPr/>
+          <p:cNvSpPr txBox="1"/>
           <p:nvPr/>
         </p:nvSpPr>
         <p:spPr>
           <a:xfrm>
-            <a:off x="762000" y="6121400"/>
-            <a:ext cx="7620000" cy="381000"/>
+            <a:off x="762000" y="6223000"/>
+            <a:ext cx="10668000" cy="355600"/>
           </a:xfrm>
           <a:prstGeom prst="rect">
             <a:avLst/>
@@ -3227,13 +3406,13 @@
       </p:sp>
       <p:sp>
         <p:nvSpPr>
-          <p:cNvPr id="4" name="New shape" title=""/>
-          <p:cNvSpPr/>
+          <p:cNvPr id="4" name="Title" title=""/>
+          <p:cNvSpPr txBox="1"/>
           <p:nvPr/>
         </p:nvSpPr>
         <p:spPr>
           <a:xfrm>
-            <a:off x="889000" y="838200"/>
+            <a:off x="889000" y="762000"/>
             <a:ext cx="10414000" cy="635000"/>
           </a:xfrm>
           <a:prstGeom prst="rect">
@@ -3278,13 +3457,13 @@
       </p:sp>
       <p:sp>
         <p:nvSpPr>
-          <p:cNvPr id="5" name="New shape" title=""/>
+          <p:cNvPr id="5" name="Accent rule" title=""/>
           <p:cNvSpPr/>
           <p:nvPr/>
         </p:nvSpPr>
         <p:spPr>
           <a:xfrm>
-            <a:off x="914400" y="1574800"/>
+            <a:off x="914400" y="1498600"/>
             <a:ext cx="965200" cy="50800"/>
           </a:xfrm>
           <a:prstGeom prst="rect">
@@ -3323,14 +3502,14 @@
       </p:sp>
       <p:sp>
         <p:nvSpPr>
-          <p:cNvPr id="6" name="New shape" title=""/>
+          <p:cNvPr id="6" name="Bullets" title=""/>
           <p:cNvSpPr/>
           <p:nvPr/>
         </p:nvSpPr>
         <p:spPr>
           <a:xfrm>
-            <a:off x="889000" y="2133600"/>
-            <a:ext cx="7366000" cy="3556000"/>
+            <a:off x="889000" y="2032000"/>
+            <a:ext cx="10414000" cy="3556000"/>
           </a:xfrm>
           <a:prstGeom prst="rect">
             <a:avLst/>
@@ -3439,14 +3618,14 @@
       </p:sp>
       <p:sp>
         <p:nvSpPr>
-          <p:cNvPr id="7" name="New shape" title=""/>
-          <p:cNvSpPr/>
+          <p:cNvPr id="7" name="Footer" title=""/>
+          <p:cNvSpPr txBox="1"/>
           <p:nvPr/>
         </p:nvSpPr>
         <p:spPr>
           <a:xfrm>
             <a:off x="889000" y="6324600"/>
-            <a:ext cx="7366000" cy="279400"/>
+            <a:ext cx="10414000" cy="279400"/>
           </a:xfrm>
           <a:prstGeom prst="rect">
             <a:avLst/>
@@ -3503,9 +3682,10 @@
   <p:cSld name="">
     <p:bg>
       <p:bgPr>
-        <a:solidFill>
-          <a:srgbClr val="FFFFFF"/>
-        </a:solidFill>
+        <a:blipFill>
+          <a:blip r:embed="rId3"/>
+          <a:tile tx="0" ty="0" sx="100000" sy="100000" flip="none" algn="tl"/>
+        </a:blipFill>
       </p:bgPr>
     </p:bg>
     <p:spTree>
@@ -3556,13 +3736,13 @@
       </p:sp>
       <p:sp>
         <p:nvSpPr>
-          <p:cNvPr id="4" name="New shape" title=""/>
-          <p:cNvSpPr/>
+          <p:cNvPr id="4" name="Title" title=""/>
+          <p:cNvSpPr txBox="1"/>
           <p:nvPr/>
         </p:nvSpPr>
         <p:spPr>
           <a:xfrm>
-            <a:off x="889000" y="838200"/>
+            <a:off x="889000" y="762000"/>
             <a:ext cx="10414000" cy="635000"/>
           </a:xfrm>
           <a:prstGeom prst="rect">
@@ -3607,13 +3787,13 @@
       </p:sp>
       <p:sp>
         <p:nvSpPr>
-          <p:cNvPr id="5" name="New shape" title=""/>
+          <p:cNvPr id="5" name="Accent rule" title=""/>
           <p:cNvSpPr/>
           <p:nvPr/>
         </p:nvSpPr>
         <p:spPr>
           <a:xfrm>
-            <a:off x="914400" y="1574800"/>
+            <a:off x="914400" y="1498600"/>
             <a:ext cx="965200" cy="50800"/>
           </a:xfrm>
           <a:prstGeom prst="rect">
@@ -3652,7 +3832,7 @@
       </p:sp>
       <p:pic>
         <p:nvPicPr>
-          <p:cNvPr id="6" name="New picture" title=""/>
+          <p:cNvPr id="6" name="Photo: Espresso Dusk" title=""/>
           <p:cNvPicPr/>
           <p:nvPr/>
         </p:nvPicPr>
@@ -3664,8 +3844,8 @@
         </p:blipFill>
         <p:spPr>
           <a:xfrm>
-            <a:off x="889000" y="2032000"/>
-            <a:ext cx="7366000" cy="3683000"/>
+            <a:off x="3048000" y="1714500"/>
+            <a:ext cx="6096000" cy="3810000"/>
           </a:xfrm>
           <a:prstGeom prst="rect">
             <a:avLst/>
@@ -3675,13 +3855,13 @@
       <p:sp>
         <p:nvSpPr>
           <p:cNvPr id="7" name="New shape" title=""/>
-          <p:cNvSpPr/>
+          <p:cNvSpPr txBox="1"/>
           <p:nvPr/>
         </p:nvSpPr>
         <p:spPr>
           <a:xfrm>
-            <a:off x="889000" y="5791200"/>
-            <a:ext cx="7366000" cy="304800"/>
+            <a:off x="3048000" y="5626100"/>
+            <a:ext cx="6096000" cy="304800"/>
           </a:xfrm>
           <a:prstGeom prst="rect">
             <a:avLst/>
@@ -3718,21 +3898,21 @@
                   <a:srgbClr val="5B6472"/>
                 </a:solidFill>
               </a:rPr>
-              <a:t>Northern Light series — on-location photography</a:t>
-            </a:r>
-          </a:p>
-        </p:txBody>
-      </p:sp>
-      <p:sp>
-        <p:nvSpPr>
-          <p:cNvPr id="8" name="New shape" title=""/>
-          <p:cNvSpPr/>
+              <a:t>Espresso Dusk — on-location photography</a:t>
+            </a:r>
+          </a:p>
+        </p:txBody>
+      </p:sp>
+      <p:sp>
+        <p:nvSpPr>
+          <p:cNvPr id="8" name="Footer" title=""/>
+          <p:cNvSpPr txBox="1"/>
           <p:nvPr/>
         </p:nvSpPr>
         <p:spPr>
           <a:xfrm>
             <a:off x="889000" y="6324600"/>
-            <a:ext cx="7366000" cy="279400"/>
+            <a:ext cx="10414000" cy="279400"/>
           </a:xfrm>
           <a:prstGeom prst="rect">
             <a:avLst/>
@@ -3842,13 +4022,13 @@
       </p:sp>
       <p:sp>
         <p:nvSpPr>
-          <p:cNvPr id="4" name="New shape" title=""/>
-          <p:cNvSpPr/>
+          <p:cNvPr id="4" name="Title" title=""/>
+          <p:cNvSpPr txBox="1"/>
           <p:nvPr/>
         </p:nvSpPr>
         <p:spPr>
           <a:xfrm>
-            <a:off x="889000" y="838200"/>
+            <a:off x="889000" y="762000"/>
             <a:ext cx="10414000" cy="635000"/>
           </a:xfrm>
           <a:prstGeom prst="rect">
@@ -3886,20 +4066,20 @@
                   <a:srgbClr val="1B2A4A"/>
                 </a:solidFill>
               </a:rPr>
-              <a:t>Engagement &amp; next steps</a:t>
-            </a:r>
-          </a:p>
-        </p:txBody>
-      </p:sp>
-      <p:sp>
-        <p:nvSpPr>
-          <p:cNvPr id="5" name="New shape" title=""/>
+              <a:t>Campaign results</a:t>
+            </a:r>
+          </a:p>
+        </p:txBody>
+      </p:sp>
+      <p:sp>
+        <p:nvSpPr>
+          <p:cNvPr id="5" name="Accent rule" title=""/>
           <p:cNvSpPr/>
           <p:nvPr/>
         </p:nvSpPr>
         <p:spPr>
           <a:xfrm>
-            <a:off x="914400" y="1574800"/>
+            <a:off x="914400" y="1498600"/>
             <a:ext cx="965200" cy="50800"/>
           </a:xfrm>
           <a:prstGeom prst="rect">
@@ -3936,16 +4116,32 @@
           </a:p>
         </p:txBody>
       </p:sp>
-      <p:sp>
-        <p:nvSpPr>
-          <p:cNvPr id="6" name="New shape" title=""/>
-          <p:cNvSpPr/>
+      <p:graphicFrame>
+        <p:nvGraphicFramePr>
+          <p:cNvPr id="6" name="Reach by channel" title=""/>
+          <p:cNvGraphicFramePr/>
+          <p:nvPr/>
+        </p:nvGraphicFramePr>
+        <p:xfrm>
+          <a:off x="889000" y="1905000"/>
+          <a:ext cx="10414000" cy="3937000"/>
+        </p:xfrm>
+        <a:graphic>
+          <a:graphicData uri="http://schemas.openxmlformats.org/drawingml/2006/chart">
+            <c:chart xmlns:c="http://schemas.openxmlformats.org/drawingml/2006/chart" r:id="rId2"/>
+          </a:graphicData>
+        </a:graphic>
+      </p:graphicFrame>
+      <p:sp>
+        <p:nvSpPr>
+          <p:cNvPr id="7" name="Footer" title=""/>
+          <p:cNvSpPr txBox="1"/>
           <p:nvPr/>
         </p:nvSpPr>
         <p:spPr>
           <a:xfrm>
-            <a:off x="889000" y="2133600"/>
-            <a:ext cx="7366000" cy="3556000"/>
+            <a:off x="889000" y="6324600"/>
+            <a:ext cx="10414000" cy="279400"/>
           </a:xfrm>
           <a:prstGeom prst="rect">
             <a:avLst/>
@@ -3975,93 +4171,94 @@
           <a:bodyPr lIns="0" rIns="0" rtlCol="0" anchor="t"/>
           <a:lstStyle/>
           <a:p>
-            <a:pPr marL="330200" indent="-330200" algn="l">
-              <a:spcAft>
-                <a:spcPct val="18000"/>
-              </a:spcAft>
-              <a:buClr>
-                <a:srgbClr val="E8A33D"/>
-              </a:buClr>
-              <a:buChar char="•"/>
-            </a:pPr>
-            <a:r>
-              <a:rPr sz="1800" b="0">
+            <a:pPr algn="l"/>
+            <a:r>
+              <a:rPr sz="1000" b="1">
                 <a:solidFill>
                   <a:srgbClr val="5B6472"/>
                 </a:solidFill>
               </a:rPr>
-              <a:t>Phase 1 — Discovery workshop and creative brief.</a:t>
-            </a:r>
-          </a:p>
-          <a:p>
-            <a:pPr marL="330200" indent="-330200" algn="l">
-              <a:spcAft>
-                <a:spcPct val="18000"/>
-              </a:spcAft>
-              <a:buClr>
-                <a:srgbClr val="E8A33D"/>
-              </a:buClr>
-              <a:buChar char="•"/>
-            </a:pPr>
-            <a:r>
-              <a:rPr sz="1800" b="0">
-                <a:solidFill>
-                  <a:srgbClr val="5B6472"/>
-                </a:solidFill>
-              </a:rPr>
-              <a:t>Phase 2 — Photography and brand system design.</a:t>
-            </a:r>
-          </a:p>
-          <a:p>
-            <a:pPr marL="330200" indent="-330200" algn="l">
-              <a:spcAft>
-                <a:spcPct val="18000"/>
-              </a:spcAft>
-              <a:buClr>
-                <a:srgbClr val="E8A33D"/>
-              </a:buClr>
-              <a:buChar char="•"/>
-            </a:pPr>
-            <a:r>
-              <a:rPr sz="1800" b="0">
-                <a:solidFill>
-                  <a:srgbClr val="5B6472"/>
-                </a:solidFill>
-              </a:rPr>
-              <a:t>Phase 3 — Motion pack and brand film.</a:t>
-            </a:r>
-          </a:p>
-          <a:p>
-            <a:pPr marL="330200" indent="-330200" algn="l">
-              <a:spcAft>
-                <a:spcPct val="18000"/>
-              </a:spcAft>
-              <a:buClr>
-                <a:srgbClr val="E8A33D"/>
-              </a:buClr>
-              <a:buChar char="•"/>
-            </a:pPr>
-            <a:r>
-              <a:rPr sz="1800" b="0">
-                <a:solidFill>
-                  <a:srgbClr val="5B6472"/>
-                </a:solidFill>
-              </a:rPr>
-              <a:t>Fixed project fee: $29,700. Start within two weeks of sign-off.</a:t>
-            </a:r>
-          </a:p>
-        </p:txBody>
-      </p:sp>
-      <p:sp>
-        <p:nvSpPr>
-          <p:cNvPr id="7" name="New shape" title=""/>
-          <p:cNvSpPr/>
+              <a:t>AURORA VISUALS  ·  Brand Pitch</a:t>
+            </a:r>
+          </a:p>
+        </p:txBody>
+      </p:sp>
+    </p:spTree>
+  </p:cSld>
+  <p:clrMapOvr>
+    <a:masterClrMapping/>
+  </p:clrMapOvr>
+  <p:transition/>
+  <p:timing/>
+</p:sld>
+</file>
+
+<file path=ppt/slides/slide5.xml><?xml version="1.0" encoding="utf-8"?>
+<p:sld xmlns:a="http://schemas.openxmlformats.org/drawingml/2006/main" xmlns:r="http://schemas.openxmlformats.org/officeDocument/2006/relationships" xmlns:m="http://schemas.openxmlformats.org/officeDocument/2006/math" xmlns:w="http://schemas.openxmlformats.org/wordprocessingml/2006/main" xmlns:wp="http://schemas.openxmlformats.org/drawingml/2006/wordprocessingDrawing" xmlns:a14="http://schemas.microsoft.com/office/drawing/2010/main" xmlns:mc="http://schemas.openxmlformats.org/markup-compatibility/2006" xmlns:p14="http://schemas.microsoft.com/office/powerpoint/2010/main" xmlns:p15="http://schemas.microsoft.com/office/powerpoint/2012/main" xmlns:p159="http://schemas.microsoft.com/office/powerpoint/2015/09/main" xmlns:p="http://schemas.openxmlformats.org/presentationml/2006/main">
+  <p:cSld name="">
+    <p:bg>
+      <p:bgPr>
+        <a:solidFill>
+          <a:srgbClr val="FFFFFF"/>
+        </a:solidFill>
+      </p:bgPr>
+    </p:bg>
+    <p:spTree>
+      <p:nvGrpSpPr>
+        <p:cNvPr id="1" name="" title=""/>
+        <p:cNvGrpSpPr/>
+        <p:nvPr/>
+      </p:nvGrpSpPr>
+      <p:grpSpPr>
+        <a:xfrm>
+          <a:off x="0" y="0"/>
+          <a:ext cx="0" cy="0"/>
+        </a:xfrm>
+      </p:grpSpPr>
+      <p:sp>
+        <p:nvSpPr>
+          <p:cNvPr id="2" name="Title 1" title=""/>
+          <p:cNvSpPr>
+            <a:spLocks noGrp="1"/>
+          </p:cNvSpPr>
+          <p:nvPr>
+            <p:ph type="ctrTitle"/>
+          </p:nvPr>
+        </p:nvSpPr>
+        <p:spPr/>
+        <p:txBody>
+          <a:bodyPr/>
+          <a:lstStyle/>
+          <a:p/>
+        </p:txBody>
+      </p:sp>
+      <p:sp>
+        <p:nvSpPr>
+          <p:cNvPr id="3" name="Subtitle 2" title=""/>
+          <p:cNvSpPr>
+            <a:spLocks noGrp="1"/>
+          </p:cNvSpPr>
+          <p:nvPr>
+            <p:ph type="subTitle" idx="1"/>
+          </p:nvPr>
+        </p:nvSpPr>
+        <p:spPr/>
+        <p:txBody>
+          <a:bodyPr/>
+          <a:lstStyle/>
+          <a:p/>
+        </p:txBody>
+      </p:sp>
+      <p:sp>
+        <p:nvSpPr>
+          <p:cNvPr id="4" name="Title" title=""/>
+          <p:cNvSpPr txBox="1"/>
           <p:nvPr/>
         </p:nvSpPr>
         <p:spPr>
           <a:xfrm>
-            <a:off x="889000" y="6324600"/>
-            <a:ext cx="7366000" cy="279400"/>
+            <a:off x="889000" y="762000"/>
+            <a:ext cx="10414000" cy="635000"/>
           </a:xfrm>
           <a:prstGeom prst="rect">
             <a:avLst/>
@@ -4093,6 +4290,218 @@
           <a:p>
             <a:pPr algn="l"/>
             <a:r>
+              <a:rPr sz="3000" b="1">
+                <a:solidFill>
+                  <a:srgbClr val="1B2A4A"/>
+                </a:solidFill>
+              </a:rPr>
+              <a:t>Engagement &amp; next steps</a:t>
+            </a:r>
+          </a:p>
+        </p:txBody>
+      </p:sp>
+      <p:sp>
+        <p:nvSpPr>
+          <p:cNvPr id="5" name="Accent rule" title=""/>
+          <p:cNvSpPr/>
+          <p:nvPr/>
+        </p:nvSpPr>
+        <p:spPr>
+          <a:xfrm>
+            <a:off x="914400" y="1498600"/>
+            <a:ext cx="965200" cy="50800"/>
+          </a:xfrm>
+          <a:prstGeom prst="rect">
+            <a:avLst/>
+          </a:prstGeom>
+          <a:solidFill>
+            <a:srgbClr val="E8A33D"/>
+          </a:solidFill>
+          <a:ln>
+            <a:noFill/>
+          </a:ln>
+        </p:spPr>
+        <p:style>
+          <a:lnRef idx="2">
+            <a:schemeClr val="accent1">
+              <a:shade val="50000"/>
+            </a:schemeClr>
+          </a:lnRef>
+          <a:fillRef idx="1">
+            <a:schemeClr val="accent1"/>
+          </a:fillRef>
+          <a:effectRef idx="0">
+            <a:schemeClr val="accent1"/>
+          </a:effectRef>
+          <a:fontRef idx="minor">
+            <a:schemeClr val="lt1"/>
+          </a:fontRef>
+        </p:style>
+        <p:txBody>
+          <a:bodyPr rtlCol="0" anchor="ctr"/>
+          <a:lstStyle/>
+          <a:p>
+            <a:pPr algn="ctr"/>
+          </a:p>
+        </p:txBody>
+      </p:sp>
+      <p:sp>
+        <p:nvSpPr>
+          <p:cNvPr id="6" name="Bullets" title=""/>
+          <p:cNvSpPr/>
+          <p:nvPr/>
+        </p:nvSpPr>
+        <p:spPr>
+          <a:xfrm>
+            <a:off x="889000" y="2032000"/>
+            <a:ext cx="10414000" cy="3556000"/>
+          </a:xfrm>
+          <a:prstGeom prst="rect">
+            <a:avLst/>
+          </a:prstGeom>
+          <a:noFill/>
+          <a:ln>
+            <a:noFill/>
+          </a:ln>
+        </p:spPr>
+        <p:style>
+          <a:lnRef idx="2">
+            <a:schemeClr val="accent1">
+              <a:shade val="50000"/>
+            </a:schemeClr>
+          </a:lnRef>
+          <a:fillRef idx="1">
+            <a:schemeClr val="accent1"/>
+          </a:fillRef>
+          <a:effectRef idx="0">
+            <a:schemeClr val="accent1"/>
+          </a:effectRef>
+          <a:fontRef idx="minor">
+            <a:schemeClr val="lt1"/>
+          </a:fontRef>
+        </p:style>
+        <p:txBody>
+          <a:bodyPr lIns="0" rIns="0" rtlCol="0" anchor="t"/>
+          <a:lstStyle/>
+          <a:p>
+            <a:pPr marL="330200" indent="-330200" algn="l">
+              <a:spcAft>
+                <a:spcPct val="18000"/>
+              </a:spcAft>
+              <a:buClr>
+                <a:srgbClr val="E8A33D"/>
+              </a:buClr>
+              <a:buChar char="•"/>
+            </a:pPr>
+            <a:r>
+              <a:rPr sz="1800" b="0">
+                <a:solidFill>
+                  <a:srgbClr val="5B6472"/>
+                </a:solidFill>
+              </a:rPr>
+              <a:t>Phase 1 — Discovery workshop and creative brief.</a:t>
+            </a:r>
+          </a:p>
+          <a:p>
+            <a:pPr marL="330200" indent="-330200" algn="l">
+              <a:spcAft>
+                <a:spcPct val="18000"/>
+              </a:spcAft>
+              <a:buClr>
+                <a:srgbClr val="E8A33D"/>
+              </a:buClr>
+              <a:buChar char="•"/>
+            </a:pPr>
+            <a:r>
+              <a:rPr sz="1800" b="0">
+                <a:solidFill>
+                  <a:srgbClr val="5B6472"/>
+                </a:solidFill>
+              </a:rPr>
+              <a:t>Phase 2 — Photography and brand system design.</a:t>
+            </a:r>
+          </a:p>
+          <a:p>
+            <a:pPr marL="330200" indent="-330200" algn="l">
+              <a:spcAft>
+                <a:spcPct val="18000"/>
+              </a:spcAft>
+              <a:buClr>
+                <a:srgbClr val="E8A33D"/>
+              </a:buClr>
+              <a:buChar char="•"/>
+            </a:pPr>
+            <a:r>
+              <a:rPr sz="1800" b="0">
+                <a:solidFill>
+                  <a:srgbClr val="5B6472"/>
+                </a:solidFill>
+              </a:rPr>
+              <a:t>Phase 3 — Motion pack and brand film.</a:t>
+            </a:r>
+          </a:p>
+          <a:p>
+            <a:pPr marL="330200" indent="-330200" algn="l">
+              <a:spcAft>
+                <a:spcPct val="18000"/>
+              </a:spcAft>
+              <a:buClr>
+                <a:srgbClr val="E8A33D"/>
+              </a:buClr>
+              <a:buChar char="•"/>
+            </a:pPr>
+            <a:r>
+              <a:rPr sz="1800" b="0">
+                <a:solidFill>
+                  <a:srgbClr val="5B6472"/>
+                </a:solidFill>
+              </a:rPr>
+              <a:t>Fixed project fee: $29,700. Start within two weeks of sign-off.</a:t>
+            </a:r>
+          </a:p>
+        </p:txBody>
+      </p:sp>
+      <p:sp>
+        <p:nvSpPr>
+          <p:cNvPr id="7" name="Footer" title=""/>
+          <p:cNvSpPr txBox="1"/>
+          <p:nvPr/>
+        </p:nvSpPr>
+        <p:spPr>
+          <a:xfrm>
+            <a:off x="889000" y="6324600"/>
+            <a:ext cx="10414000" cy="279400"/>
+          </a:xfrm>
+          <a:prstGeom prst="rect">
+            <a:avLst/>
+          </a:prstGeom>
+          <a:noFill/>
+          <a:ln>
+            <a:noFill/>
+          </a:ln>
+        </p:spPr>
+        <p:style>
+          <a:lnRef idx="2">
+            <a:schemeClr val="accent1">
+              <a:shade val="50000"/>
+            </a:schemeClr>
+          </a:lnRef>
+          <a:fillRef idx="1">
+            <a:schemeClr val="accent1"/>
+          </a:fillRef>
+          <a:effectRef idx="0">
+            <a:schemeClr val="accent1"/>
+          </a:effectRef>
+          <a:fontRef idx="minor">
+            <a:schemeClr val="lt1"/>
+          </a:fontRef>
+        </p:style>
+        <p:txBody>
+          <a:bodyPr lIns="0" rIns="0" rtlCol="0" anchor="t"/>
+          <a:lstStyle/>
+          <a:p>
+            <a:pPr algn="l"/>
+            <a:r>
               <a:rPr sz="1000" b="1">
                 <a:solidFill>
                   <a:srgbClr val="5B6472"/>
@@ -4115,7 +4524,7 @@
 
 <file path=ppt/tags/tag1.xml><?xml version="1.0" encoding="utf-8"?>
 <p:tagLst xmlns:p="http://schemas.openxmlformats.org/presentationml/2006/main">
-  <p:tag name="AS_NET" val="10.0.0"/>
+  <p:tag name="AS_NET" val="10.0.12"/>
   <p:tag name="AS_OS" val="Microsoft Windows NT 10.0.26200.0"/>
   <p:tag name="AS_RELEASE_DATE" val="2024.11.14"/>
   <p:tag name="AS_TITLE" val="Aspose.Slides for .NET Standard 2.0"/>

</xml_diff>

<commit_message>
Update python-net docs for 26.10: outputs from the 26.10 wheel, installation and platform requirements, evaluation marks, preview callbacks and the AGENTS.md copy
</commit_message>
<xml_diff>
--- a/python-net/_output_files/developer-guide/advanced-usage/adding-watermarks/add-watermarks-to-presentation-documents/working-with-slide-backgrounds/remove_slide_background/output.pptx
+++ b/python-net/_output_files/developer-guide/advanced-usage/adding-watermarks/add-watermarks-to-presentation-documents/working-with-slide-backgrounds/remove_slide_background/output.pptx
@@ -1,6 +1,6 @@
 
 <file path=ppt/presentation.xml><?xml version="1.0" encoding="utf-8"?>
-<!--Generated by Aspose.Slides for .NET 24.11-->
+<!--Generated by Aspose.Slides for .NET 25.10-->
 <p:presentation xmlns:r="http://schemas.openxmlformats.org/officeDocument/2006/relationships" xmlns:a="http://schemas.openxmlformats.org/drawingml/2006/main" xmlns:p="http://schemas.openxmlformats.org/presentationml/2006/main" saveSubsetFonts="1">
   <p:sldMasterIdLst>
     <p:sldMasterId id="2147483648" r:id="rId1"/>
@@ -4526,9 +4526,9 @@
 <p:tagLst xmlns:p="http://schemas.openxmlformats.org/presentationml/2006/main">
   <p:tag name="AS_NET" val="10.0.12"/>
   <p:tag name="AS_OS" val="Microsoft Windows NT 10.0.26200.0"/>
-  <p:tag name="AS_RELEASE_DATE" val="2024.11.14"/>
-  <p:tag name="AS_TITLE" val="Aspose.Slides for .NET Standard 2.0"/>
-  <p:tag name="AS_VERSION" val="24.11"/>
+  <p:tag name="AS_RELEASE_DATE" val="2025.10.14"/>
+  <p:tag name="AS_TITLE" val="Aspose.Slides for .NET6"/>
+  <p:tag name="AS_VERSION" val="25.10"/>
 </p:tagLst>
 </file>
 

</xml_diff>